<commit_message>
Live demo link in README and in the deck's demo button
Co-Authored-By: Claude Opus 5.5 <noreply@anthropic.com>
</commit_message>
<xml_diff>
--- a/marketing/Preboard-Generator-Client-Deck.pptx
+++ b/marketing/Preboard-Generator-Client-Deck.pptx
@@ -115,31 +115,31 @@
   <p:extLst>
     <p:ext uri="{521415D9-36F7-43E2-AB2F-B90AF26B5E84}">
       <p14:sectionLst xmlns:p14="http://schemas.microsoft.com/office/powerpoint/2010/main">
-        <p14:section name="Opening" id="{c9976225-9d9e-b778-2751-22c6a4179cc9}">
+        <p14:section name="Opening" id="{05238e80-6741-9e4e-0f91-5dab52d57275}">
           <p14:sldIdLst>
             <p14:sldId id="256"/>
           </p14:sldIdLst>
         </p14:section>
-        <p14:section name="Problem and solution" id="{37318d3a-8b4d-a001-7c97-d9941b0c6748}">
+        <p14:section name="Problem and solution" id="{3995c706-aebe-7016-b4e7-c671786d0fdb}">
           <p14:sldIdLst>
             <p14:sldId id="257"/>
             <p14:sldId id="258"/>
           </p14:sldIdLst>
         </p14:section>
-        <p14:section name="How it works" id="{ec5da1c0-b21d-0d22-5739-284e4403837a}">
+        <p14:section name="How it works" id="{28de64ae-3779-a36d-5ee4-3685c87ef727}">
           <p14:sldIdLst>
             <p14:sldId id="259"/>
             <p14:sldId id="260"/>
           </p14:sldIdLst>
         </p14:section>
-        <p14:section name="Results" id="{435d5ac0-1279-5b81-20b4-bb9e844374b4}">
+        <p14:section name="Results" id="{78fa44d1-c615-3506-1144-5ffeaf1b6ba9}">
           <p14:sldIdLst>
             <p14:sldId id="261"/>
             <p14:sldId id="262"/>
             <p14:sldId id="263"/>
           </p14:sldIdLst>
         </p14:section>
-        <p14:section name="Live demo" id="{62a6ad1f-e48b-acde-0245-c15785466a36}">
+        <p14:section name="Live demo" id="{f019bb87-ea60-05f6-33e6-a46b0a921620}">
           <p14:sldIdLst>
             <p14:sldId id="264"/>
           </p14:sldIdLst>

</xml_diff>